<commit_message>
Exactitude : le risque « intensité carbone élevée » suit la grille sectorielle
DETTE § 24. Le risque se déclenchait au-delà de 100 t CO2e/M€ quel que soit
le secteur, pendant que la synthèse jugeait la même intensité « solide pour
le secteur » : une énergéticienne à 121 t/M€ recevait les deux. Le risque lit
désormais la tranche de bands.classer (fragile ou critique). Sur 300 profils,
181 → 168 dossiers exposés. Exemples, captures et vignettes régénérés.

Co-Authored-By: Claude Opus 5.5 <noreply@anthropic.com>
</commit_message>
<xml_diff>
--- a/examples/Presentation.pptx
+++ b/examples/Presentation.pptx
@@ -939,7 +939,7 @@
           <a:lstStyle/>
           <a:p>
             <a:r>
-              <a:t>Le dossier d'Acme Industries fait ressortir 2 enjeux et un point d'appui. Les fragilités se concentrent sur le pilier de gouvernance : l'intégrité et la sécurité de l'information et le pilotage de la démarche. C'est là que le plan d'action doit porter en premier.</a:t>
+              <a:t>Le dossier d'Acme Industries fait ressortir 2 enjeux et un point d'appui. Les enjeux repérés relèvent surtout du pilier de gouvernance : l'intégrité et la sécurité de l'information et le pilotage de la démarche. C'est là que le plan d'action doit porter en premier.</a:t>
             </a:r>
           </a:p>
           <a:p/>
@@ -16826,7 +16826,7 @@
                 </a:solidFill>
                 <a:latin typeface="Segoe UI"/>
               </a:rPr>
-              <a:t>Intensité carbone élevée : marge exposée à la tarification du carbone</a:t>
+              <a:t>Dépendance énergie fossile : exposition à la hausse des prix</a:t>
             </a:r>
           </a:p>
         </p:txBody>

</xml_diff>

<commit_message>
Étape B, lot 1 : trajectoire climat déclarée par le client
DETTE § 0bis. Nouvelle étape « Objectifs » du wizard : réduction visée,
année de référence, année cible, périmètre (scopes 1-2 ou 1-2-3). Une cible
complète est citée comme déclarée par l'entreprise, avec le rythme annuel
moyen et, si la référence est l'exercice du rapport, la cible en tonnes ;
jamais d'alignement 1,5 °C ou SBTi (règle 9). Texte « Objectifs », ligne
ESRS E1-4 (« cible déclarée »), livre blanc, questionnaire, import CSV.
Une saisie partielle vaut absence. Les anciens dossiers se relisent sans
changement. Invariant du banc : cible_citee_est_la_cible_saisie.
Relevé : DETTE § 25 (trois libellés d'interface).

Co-Authored-By: Claude Opus 5.5 <noreply@anthropic.com>
</commit_message>
<xml_diff>
--- a/examples/Presentation.pptx
+++ b/examples/Presentation.pptx
@@ -1615,7 +1615,7 @@
           <a:p/>
           <a:p>
             <a:r>
-              <a:t>Le tableau ci-dessous examine 6 exigences de reporting du référentiel CSRD / ESRS : 4 sont couvertes par les données de l'exercice, 1 reste ouverte ou partiellement couverte. Chaque ligne indique la référence concernée et ce qui manque pour la couvrir.</a:t>
+              <a:t>Le tableau ci-dessous examine 6 exigences de reporting du référentiel CSRD / ESRS : 5 sont couvertes par les données de l'exercice, 1 reste ouverte ou partiellement couverte. Chaque ligne indique la référence concernée et ce qui manque pour la couvrir.</a:t>
             </a:r>
           </a:p>
         </p:txBody>
@@ -6703,7 +6703,7 @@
             <a:avLst/>
           </a:prstGeom>
           <a:solidFill>
-            <a:srgbClr val="7F8C8D"/>
+            <a:srgbClr val="37474F"/>
           </a:solidFill>
           <a:ln>
             <a:noFill/>
@@ -6761,7 +6761,7 @@
                 </a:solidFill>
                 <a:latin typeface="Segoe UI"/>
               </a:rPr>
-              <a:t>Non couvert par ce reporting</a:t>
+              <a:t>Publié</a:t>
             </a:r>
           </a:p>
         </p:txBody>
@@ -6796,7 +6796,7 @@
                 </a:solidFill>
                 <a:latin typeface="Segoe UI"/>
               </a:rPr>
-              <a:t>Cibles climatiques non documentées dans ce reporting</a:t>
+              <a:t>Cible déclarée : −42 % entre 2025 et 2030 (scopes 1 et 2)</a:t>
             </a:r>
           </a:p>
         </p:txBody>

</xml_diff>

<commit_message>
Étape B, lot 2 : cibles par indicateur et écart à la cible
Renouvelable, part de femmes, heures de formation, taux de fréquence, à
l'horizon des objectifs. Le texte « Objectifs » et la lecture de chaque
pilier donnent l'écart à combler (ou « cible déjà atteinte », ou valeur de
l'exercice non renseignée). La cible du client remplace l'objectif proposé
par l'outil : point faible (« objectif 50 % »), recommandations, titre et
colonne Objectif du plan d'action. Questionnaire, import CSV, interface.
Invariant du banc : cibles_indicateurs_citees_telles_quelles.

Co-Authored-By: Claude Opus 5.5 <noreply@anthropic.com>
</commit_message>
<xml_diff>
--- a/examples/Presentation.pptx
+++ b/examples/Presentation.pptx
@@ -1033,13 +1033,13 @@
           <a:p/>
           <a:p>
             <a:r>
-              <a:t>La consommation d'énergie atteint 21 500 MWh, soit 67,2 MWh par salarié. La consommation d'eau de l'exercice est de 120 000 m3. Restent à documenter : le volume de déchets et les initiatives en faveur de la biodiversité. Leur collecte, au prochain exercice, fiabilisera la lecture de ce pilier.</a:t>
+              <a:t>La consommation d'énergie atteint 21 500 MWh, soit 67,2 MWh par salarié. La consommation d'eau de l'exercice est de 120 000 m3. Restent à documenter : le volume de déchets et les initiatives en faveur de la biodiversité. Leur collecte, au prochain exercice, fiabilisera la lecture de ce pilier. L'entreprise s'est fixé, à horizon 2030, les cibles suivantes : part d'énergie renouvelable : 60 % (42 % sur l'exercice, soit 18 points à gagner d'ici 2030).</a:t>
             </a:r>
           </a:p>
           <a:p/>
           <a:p>
             <a:r>
-              <a:t>Le plan d'action retient un levier pour ce pilier : augmenter la part d'énergie renouvelable à 50 % (objectif : 50 % d'énergie renouvelable dans le mix ; échéance : 2027).</a:t>
+              <a:t>Le plan d'action retient un levier pour ce pilier : atteindre la cible de 60 % d'énergie renouvelable fixée pour 2030 (objectif : cible de l'entreprise : 60 % en 2030 ; échéance : 2027).</a:t>
             </a:r>
           </a:p>
           <a:p/>
@@ -1245,7 +1245,7 @@
           <a:p/>
           <a:p>
             <a:r>
-              <a:t>L'effectif s'établit à 320 collaborateurs sur l'exercice. Restent à documenter : le nombre d'accidents du travail, l'investissement communautaire, la part d'achats locaux, la satisfaction client et l'emploi de personnes en situation de handicap. Leur collecte, au prochain exercice, fiabilisera la lecture de ce pilier.</a:t>
+              <a:t>L'effectif s'établit à 320 collaborateurs sur l'exercice. Restent à documenter : le nombre d'accidents du travail, l'investissement communautaire, la part d'achats locaux, la satisfaction client et l'emploi de personnes en situation de handicap. Leur collecte, au prochain exercice, fiabilisera la lecture de ce pilier. L'entreprise s'est fixé, à horizon 2030, les cibles suivantes : heures de formation par salarié : 30 h (22 h sur l'exercice, soit 8 h à gagner d'ici 2030).</a:t>
             </a:r>
           </a:p>
           <a:p/>
@@ -15792,7 +15792,7 @@
                 </a:solidFill>
                 <a:latin typeface="Segoe UI"/>
               </a:rPr>
-              <a:t>Énergie renouvelable à renforcer (actuellement 42 %, objectif 50 %)</a:t>
+              <a:t>Énergie renouvelable à renforcer (actuellement 42 %, cible de l'entreprise : 60 % en 2030)</a:t>
             </a:r>
           </a:p>
         </p:txBody>
@@ -18957,7 +18957,7 @@
                 </a:solidFill>
                 <a:latin typeface="Georgia"/>
               </a:rPr>
-              <a:t>Augmenter la part d'énergie renouvelable à 50 %</a:t>
+              <a:t>Atteindre la cible de 60 % d'énergie renouvelable fixée pour 2030</a:t>
             </a:r>
           </a:p>
         </p:txBody>
@@ -21087,7 +21087,7 @@
                 </a:solidFill>
                 <a:latin typeface="Segoe UI"/>
               </a:rPr>
-              <a:t>Augmenter la part d'énergie renouvelable à 50 %</a:t>
+              <a:t>Atteindre la cible de 60 % d'énergie renouvelable fixée pour 2030</a:t>
             </a:r>
           </a:p>
         </p:txBody>
@@ -22079,7 +22079,7 @@
                 </a:solidFill>
                 <a:latin typeface="Segoe UI"/>
               </a:rPr>
-              <a:t>Augmenter la part d'énergie renouvelable à 50 %</a:t>
+              <a:t>Atteindre la cible de 60 % d'énergie renouvelable fixée pour 2030</a:t>
             </a:r>
           </a:p>
         </p:txBody>

</xml_diff>

<commit_message>
Évolution depuis l'exercice N-1, indicateur par indicateur
Comparaison N-1, lot C (DETTE § 0). evolution.py compare chaque indicateur
présent sur les deux exercices : variation, lecture « en progrès / en
recul / stable » tirée de bands (grilles et compteurs de pénalité) — sans
jugement quand bands n'en définit pas —, intensité carbone plutôt que
tonnes, indicateurs apparus ou disparus. Section en tête du Diagnostic
(PDF, Word, notes PPTX) ; le classement interne des piliers reste en repli.

Cause racine d'un défaut de rendu : pdf_kit.clean supprimait en silence tout
caractère hors cp1252 (« −26,9 » s'imprimait « 26,9 », « 0 → 1 » « 0 1 ») ;
« − » et « → » sont translittérés, et le banc vérifie désormais qu'aucun
caractère ne se perd à l'impression. Relevé : DETTE § 26.

Co-Authored-By: Claude Opus 5.5 <noreply@anthropic.com>
</commit_message>
<xml_diff>
--- a/examples/Presentation.pptx
+++ b/examples/Presentation.pptx
@@ -1604,6 +1604,12 @@
           <a:p>
             <a:r>
               <a:t>Ce chapitre met en regard les résultats et leurs causes. Il identifie 5 forces et 4 axes de progrès, examine la couverture de 6 exigences de reporting (dont 1 encore ouverte) et hiérarchise 4 risques majeurs (dont 1 de priorité 1).</a:t>
+            </a:r>
+          </a:p>
+          <a:p/>
+          <a:p>
+            <a:r>
+              <a:t>Par rapport à l'exercice 2024, 17 indicateurs sont comparables : 7 en progrès, 1 en recul, 5 stables, 4 sans sens de lecture défini. Principales évolutions : les incidents de cybersécurité de 0 à 1 (+1) ; le taux de fréquence des accidents de 8,1 à 6,2 (-1,9) ; les heures de formation de 18 h à 22 h (+4 h) ; la part d'énergie renouvelable de 35 % à 42 % (+7 pts).</a:t>
             </a:r>
           </a:p>
           <a:p/>
@@ -6796,7 +6802,7 @@
                 </a:solidFill>
                 <a:latin typeface="Segoe UI"/>
               </a:rPr>
-              <a:t>Cible déclarée : −42 % entre 2025 et 2030 (scopes 1 et 2)</a:t>
+              <a:t>Cible déclarée : -42 % entre 2025 et 2030 (scopes 1 et 2)</a:t>
             </a:r>
           </a:p>
         </p:txBody>
@@ -24237,7 +24243,7 @@
                 </a:solidFill>
                 <a:latin typeface="Segoe UI"/>
               </a:rPr>
-              <a:t>+14 pts  vs 2024</a:t>
+              <a:t>+6 pts  vs 2024</a:t>
             </a:r>
           </a:p>
         </p:txBody>

</xml_diff>

<commit_message>
Exactitude : les titres de pilier ne nomment plus de dispositif non déclaré
DETTE § 26. Choisis par tranche de score, les titres affirmaient « audit »,
« assurance externe », « comité », « Scope 3 » ou « capital humain sécurisé »
quelle que soit la donnée : « Gouvernance exemplaire : indépendance, audit…
» s'imprimait à côté de « Audit ESG : Non ». Les 24 titres (FR/EN) lisent
désormais la tranche sur la grille du diagnostic. Les titres entrent dans le
banc de cohérence, qui ne les voyait pas.

Co-Authored-By: Claude Opus 5.5 <noreply@anthropic.com>
</commit_message>
<xml_diff>
--- a/examples/Presentation.pptx
+++ b/examples/Presentation.pptx
@@ -8544,7 +8544,7 @@
                 </a:solidFill>
                 <a:latin typeface="Segoe UI"/>
               </a:rPr>
-              <a:t>Performance environnementale solide ; l'intensité carbone reste le principal levier de création de valeur durable.</a:t>
+              <a:t>Performance environnementale solide ; les indicateurs les moins bien placés sur la grille sont les prochains leviers.</a:t>
             </a:r>
           </a:p>
         </p:txBody>
@@ -10853,7 +10853,7 @@
                 </a:solidFill>
                 <a:latin typeface="Segoe UI"/>
               </a:rPr>
-              <a:t>Socle social solide ; la diversité et la formation sont les leviers pour transformer la conformité en avantage compétitif.</a:t>
+              <a:t>Socle social solide ; les indicateurs les moins bien placés sur la grille sont les leviers pour transformer la conformité en avantage.</a:t>
             </a:r>
           </a:p>
         </p:txBody>
@@ -13006,7 +13006,7 @@
                 </a:solidFill>
                 <a:latin typeface="Segoe UI"/>
               </a:rPr>
-              <a:t>Gouvernance exemplaire : indépendance, audit et supervision ESG inspirent confiance aux investisseurs.</a:t>
+              <a:t>Gouvernance de premier plan sur la grille du diagnostic : un gage de confiance pour les investisseurs.</a:t>
             </a:r>
           </a:p>
         </p:txBody>

</xml_diff>